<commit_message>
Add thematic photos to each slide in measles presentation
</commit_message>
<xml_diff>
--- a/Presentation/Презентація_Кір_у_дітей.pptx
+++ b/Presentation/Презентація_Кір_у_дітей.pptx
@@ -3308,6 +3308,30 @@
           </a:p>
         </p:txBody>
       </p:sp>
+      <p:pic>
+        <p:nvPicPr>
+          <p:cNvPr id="4" name="Picture 3" descr="slide_01.jpg"/>
+          <p:cNvPicPr>
+            <a:picLocks noChangeAspect="1"/>
+          </p:cNvPicPr>
+          <p:nvPr/>
+        </p:nvPicPr>
+        <p:blipFill>
+          <a:blip r:embed="rId2"/>
+          <a:stretch>
+            <a:fillRect/>
+          </a:stretch>
+        </p:blipFill>
+        <p:spPr>
+          <a:xfrm>
+            <a:off x="5623560" y="3611880"/>
+            <a:ext cx="3246120" cy="2423160"/>
+          </a:xfrm>
+          <a:prstGeom prst="rect">
+            <a:avLst/>
+          </a:prstGeom>
+        </p:spPr>
+      </p:pic>
     </p:spTree>
   </p:cSld>
   <p:clrMapOvr>
@@ -3394,6 +3418,30 @@
           </a:p>
         </p:txBody>
       </p:sp>
+      <p:pic>
+        <p:nvPicPr>
+          <p:cNvPr id="4" name="Picture 3" descr="slide_10.jpg"/>
+          <p:cNvPicPr>
+            <a:picLocks noChangeAspect="1"/>
+          </p:cNvPicPr>
+          <p:nvPr/>
+        </p:nvPicPr>
+        <p:blipFill>
+          <a:blip r:embed="rId2"/>
+          <a:stretch>
+            <a:fillRect/>
+          </a:stretch>
+        </p:blipFill>
+        <p:spPr>
+          <a:xfrm>
+            <a:off x="5623560" y="3611880"/>
+            <a:ext cx="3246120" cy="2423160"/>
+          </a:xfrm>
+          <a:prstGeom prst="rect">
+            <a:avLst/>
+          </a:prstGeom>
+        </p:spPr>
+      </p:pic>
     </p:spTree>
   </p:cSld>
   <p:clrMapOvr>
@@ -3496,6 +3544,30 @@
           </a:p>
         </p:txBody>
       </p:sp>
+      <p:pic>
+        <p:nvPicPr>
+          <p:cNvPr id="4" name="Picture 3" descr="slide_05.jpg"/>
+          <p:cNvPicPr>
+            <a:picLocks noChangeAspect="1"/>
+          </p:cNvPicPr>
+          <p:nvPr/>
+        </p:nvPicPr>
+        <p:blipFill>
+          <a:blip r:embed="rId2"/>
+          <a:stretch>
+            <a:fillRect/>
+          </a:stretch>
+        </p:blipFill>
+        <p:spPr>
+          <a:xfrm>
+            <a:off x="5623560" y="3611880"/>
+            <a:ext cx="3246120" cy="2423160"/>
+          </a:xfrm>
+          <a:prstGeom prst="rect">
+            <a:avLst/>
+          </a:prstGeom>
+        </p:spPr>
+      </p:pic>
     </p:spTree>
   </p:cSld>
   <p:clrMapOvr>
@@ -3594,6 +3666,30 @@
           </a:p>
         </p:txBody>
       </p:sp>
+      <p:pic>
+        <p:nvPicPr>
+          <p:cNvPr id="4" name="Picture 3" descr="slide_06.jpg"/>
+          <p:cNvPicPr>
+            <a:picLocks noChangeAspect="1"/>
+          </p:cNvPicPr>
+          <p:nvPr/>
+        </p:nvPicPr>
+        <p:blipFill>
+          <a:blip r:embed="rId2"/>
+          <a:stretch>
+            <a:fillRect/>
+          </a:stretch>
+        </p:blipFill>
+        <p:spPr>
+          <a:xfrm>
+            <a:off x="5623560" y="3611880"/>
+            <a:ext cx="3246120" cy="2423160"/>
+          </a:xfrm>
+          <a:prstGeom prst="rect">
+            <a:avLst/>
+          </a:prstGeom>
+        </p:spPr>
+      </p:pic>
     </p:spTree>
   </p:cSld>
   <p:clrMapOvr>
@@ -3688,6 +3784,30 @@
           </a:p>
         </p:txBody>
       </p:sp>
+      <p:pic>
+        <p:nvPicPr>
+          <p:cNvPr id="4" name="Picture 3" descr="slide_13.jpg"/>
+          <p:cNvPicPr>
+            <a:picLocks noChangeAspect="1"/>
+          </p:cNvPicPr>
+          <p:nvPr/>
+        </p:nvPicPr>
+        <p:blipFill>
+          <a:blip r:embed="rId2"/>
+          <a:stretch>
+            <a:fillRect/>
+          </a:stretch>
+        </p:blipFill>
+        <p:spPr>
+          <a:xfrm>
+            <a:off x="5623560" y="3611880"/>
+            <a:ext cx="3246120" cy="2423160"/>
+          </a:xfrm>
+          <a:prstGeom prst="rect">
+            <a:avLst/>
+          </a:prstGeom>
+        </p:spPr>
+      </p:pic>
     </p:spTree>
   </p:cSld>
   <p:clrMapOvr>
@@ -3788,6 +3908,30 @@
           </a:p>
         </p:txBody>
       </p:sp>
+      <p:pic>
+        <p:nvPicPr>
+          <p:cNvPr id="4" name="Picture 3" descr="slide_14.jpg"/>
+          <p:cNvPicPr>
+            <a:picLocks noChangeAspect="1"/>
+          </p:cNvPicPr>
+          <p:nvPr/>
+        </p:nvPicPr>
+        <p:blipFill>
+          <a:blip r:embed="rId2"/>
+          <a:stretch>
+            <a:fillRect/>
+          </a:stretch>
+        </p:blipFill>
+        <p:spPr>
+          <a:xfrm>
+            <a:off x="5623560" y="3611880"/>
+            <a:ext cx="3246120" cy="2423160"/>
+          </a:xfrm>
+          <a:prstGeom prst="rect">
+            <a:avLst/>
+          </a:prstGeom>
+        </p:spPr>
+      </p:pic>
     </p:spTree>
   </p:cSld>
   <p:clrMapOvr>
@@ -3882,6 +4026,30 @@
           </a:p>
         </p:txBody>
       </p:sp>
+      <p:pic>
+        <p:nvPicPr>
+          <p:cNvPr id="4" name="Picture 3" descr="slide_15.jpg"/>
+          <p:cNvPicPr>
+            <a:picLocks noChangeAspect="1"/>
+          </p:cNvPicPr>
+          <p:nvPr/>
+        </p:nvPicPr>
+        <p:blipFill>
+          <a:blip r:embed="rId2"/>
+          <a:stretch>
+            <a:fillRect/>
+          </a:stretch>
+        </p:blipFill>
+        <p:spPr>
+          <a:xfrm>
+            <a:off x="5623560" y="3611880"/>
+            <a:ext cx="3246120" cy="2423160"/>
+          </a:xfrm>
+          <a:prstGeom prst="rect">
+            <a:avLst/>
+          </a:prstGeom>
+        </p:spPr>
+      </p:pic>
     </p:spTree>
   </p:cSld>
   <p:clrMapOvr>
@@ -3990,6 +4158,30 @@
           </a:p>
         </p:txBody>
       </p:sp>
+      <p:pic>
+        <p:nvPicPr>
+          <p:cNvPr id="4" name="Picture 3" descr="slide_13.jpg"/>
+          <p:cNvPicPr>
+            <a:picLocks noChangeAspect="1"/>
+          </p:cNvPicPr>
+          <p:nvPr/>
+        </p:nvPicPr>
+        <p:blipFill>
+          <a:blip r:embed="rId2"/>
+          <a:stretch>
+            <a:fillRect/>
+          </a:stretch>
+        </p:blipFill>
+        <p:spPr>
+          <a:xfrm>
+            <a:off x="5623560" y="3611880"/>
+            <a:ext cx="3246120" cy="2423160"/>
+          </a:xfrm>
+          <a:prstGeom prst="rect">
+            <a:avLst/>
+          </a:prstGeom>
+        </p:spPr>
+      </p:pic>
     </p:spTree>
   </p:cSld>
   <p:clrMapOvr>
@@ -4100,6 +4292,30 @@
           </a:p>
         </p:txBody>
       </p:sp>
+      <p:pic>
+        <p:nvPicPr>
+          <p:cNvPr id="4" name="Picture 3" descr="slide_17.jpg"/>
+          <p:cNvPicPr>
+            <a:picLocks noChangeAspect="1"/>
+          </p:cNvPicPr>
+          <p:nvPr/>
+        </p:nvPicPr>
+        <p:blipFill>
+          <a:blip r:embed="rId2"/>
+          <a:stretch>
+            <a:fillRect/>
+          </a:stretch>
+        </p:blipFill>
+        <p:spPr>
+          <a:xfrm>
+            <a:off x="5623560" y="3611880"/>
+            <a:ext cx="3246120" cy="2423160"/>
+          </a:xfrm>
+          <a:prstGeom prst="rect">
+            <a:avLst/>
+          </a:prstGeom>
+        </p:spPr>
+      </p:pic>
     </p:spTree>
   </p:cSld>
   <p:clrMapOvr>
@@ -4202,6 +4418,30 @@
           </a:p>
         </p:txBody>
       </p:sp>
+      <p:pic>
+        <p:nvPicPr>
+          <p:cNvPr id="4" name="Picture 3" descr="slide_03.jpg"/>
+          <p:cNvPicPr>
+            <a:picLocks noChangeAspect="1"/>
+          </p:cNvPicPr>
+          <p:nvPr/>
+        </p:nvPicPr>
+        <p:blipFill>
+          <a:blip r:embed="rId2"/>
+          <a:stretch>
+            <a:fillRect/>
+          </a:stretch>
+        </p:blipFill>
+        <p:spPr>
+          <a:xfrm>
+            <a:off x="5623560" y="3611880"/>
+            <a:ext cx="3246120" cy="2423160"/>
+          </a:xfrm>
+          <a:prstGeom prst="rect">
+            <a:avLst/>
+          </a:prstGeom>
+        </p:spPr>
+      </p:pic>
     </p:spTree>
   </p:cSld>
   <p:clrMapOvr>
@@ -4296,6 +4536,30 @@
           </a:p>
         </p:txBody>
       </p:sp>
+      <p:pic>
+        <p:nvPicPr>
+          <p:cNvPr id="4" name="Picture 3" descr="slide_19.jpg"/>
+          <p:cNvPicPr>
+            <a:picLocks noChangeAspect="1"/>
+          </p:cNvPicPr>
+          <p:nvPr/>
+        </p:nvPicPr>
+        <p:blipFill>
+          <a:blip r:embed="rId2"/>
+          <a:stretch>
+            <a:fillRect/>
+          </a:stretch>
+        </p:blipFill>
+        <p:spPr>
+          <a:xfrm>
+            <a:off x="5623560" y="3611880"/>
+            <a:ext cx="3246120" cy="2423160"/>
+          </a:xfrm>
+          <a:prstGeom prst="rect">
+            <a:avLst/>
+          </a:prstGeom>
+        </p:spPr>
+      </p:pic>
     </p:spTree>
   </p:cSld>
   <p:clrMapOvr>
@@ -4390,6 +4654,30 @@
           </a:p>
         </p:txBody>
       </p:sp>
+      <p:pic>
+        <p:nvPicPr>
+          <p:cNvPr id="4" name="Picture 3" descr="slide_02.jpg"/>
+          <p:cNvPicPr>
+            <a:picLocks noChangeAspect="1"/>
+          </p:cNvPicPr>
+          <p:nvPr/>
+        </p:nvPicPr>
+        <p:blipFill>
+          <a:blip r:embed="rId2"/>
+          <a:stretch>
+            <a:fillRect/>
+          </a:stretch>
+        </p:blipFill>
+        <p:spPr>
+          <a:xfrm>
+            <a:off x="5623560" y="3611880"/>
+            <a:ext cx="3246120" cy="2423160"/>
+          </a:xfrm>
+          <a:prstGeom prst="rect">
+            <a:avLst/>
+          </a:prstGeom>
+        </p:spPr>
+      </p:pic>
     </p:spTree>
   </p:cSld>
   <p:clrMapOvr>
@@ -4500,6 +4788,30 @@
           </a:p>
         </p:txBody>
       </p:sp>
+      <p:pic>
+        <p:nvPicPr>
+          <p:cNvPr id="4" name="Picture 3" descr="slide_05.jpg"/>
+          <p:cNvPicPr>
+            <a:picLocks noChangeAspect="1"/>
+          </p:cNvPicPr>
+          <p:nvPr/>
+        </p:nvPicPr>
+        <p:blipFill>
+          <a:blip r:embed="rId2"/>
+          <a:stretch>
+            <a:fillRect/>
+          </a:stretch>
+        </p:blipFill>
+        <p:spPr>
+          <a:xfrm>
+            <a:off x="5623560" y="3611880"/>
+            <a:ext cx="3246120" cy="2423160"/>
+          </a:xfrm>
+          <a:prstGeom prst="rect">
+            <a:avLst/>
+          </a:prstGeom>
+        </p:spPr>
+      </p:pic>
     </p:spTree>
   </p:cSld>
   <p:clrMapOvr>
@@ -4602,6 +4914,30 @@
           </a:p>
         </p:txBody>
       </p:sp>
+      <p:pic>
+        <p:nvPicPr>
+          <p:cNvPr id="4" name="Picture 3" descr="slide_21.jpg"/>
+          <p:cNvPicPr>
+            <a:picLocks noChangeAspect="1"/>
+          </p:cNvPicPr>
+          <p:nvPr/>
+        </p:nvPicPr>
+        <p:blipFill>
+          <a:blip r:embed="rId2"/>
+          <a:stretch>
+            <a:fillRect/>
+          </a:stretch>
+        </p:blipFill>
+        <p:spPr>
+          <a:xfrm>
+            <a:off x="5623560" y="3611880"/>
+            <a:ext cx="3246120" cy="2423160"/>
+          </a:xfrm>
+          <a:prstGeom prst="rect">
+            <a:avLst/>
+          </a:prstGeom>
+        </p:spPr>
+      </p:pic>
     </p:spTree>
   </p:cSld>
   <p:clrMapOvr>
@@ -4704,6 +5040,30 @@
           </a:p>
         </p:txBody>
       </p:sp>
+      <p:pic>
+        <p:nvPicPr>
+          <p:cNvPr id="4" name="Picture 3" descr="slide_22.jpg"/>
+          <p:cNvPicPr>
+            <a:picLocks noChangeAspect="1"/>
+          </p:cNvPicPr>
+          <p:nvPr/>
+        </p:nvPicPr>
+        <p:blipFill>
+          <a:blip r:embed="rId2"/>
+          <a:stretch>
+            <a:fillRect/>
+          </a:stretch>
+        </p:blipFill>
+        <p:spPr>
+          <a:xfrm>
+            <a:off x="5623560" y="3611880"/>
+            <a:ext cx="3246120" cy="2423160"/>
+          </a:xfrm>
+          <a:prstGeom prst="rect">
+            <a:avLst/>
+          </a:prstGeom>
+        </p:spPr>
+      </p:pic>
     </p:spTree>
   </p:cSld>
   <p:clrMapOvr>
@@ -4798,6 +5158,30 @@
           </a:p>
         </p:txBody>
       </p:sp>
+      <p:pic>
+        <p:nvPicPr>
+          <p:cNvPr id="4" name="Picture 3" descr="slide_02.jpg"/>
+          <p:cNvPicPr>
+            <a:picLocks noChangeAspect="1"/>
+          </p:cNvPicPr>
+          <p:nvPr/>
+        </p:nvPicPr>
+        <p:blipFill>
+          <a:blip r:embed="rId2"/>
+          <a:stretch>
+            <a:fillRect/>
+          </a:stretch>
+        </p:blipFill>
+        <p:spPr>
+          <a:xfrm>
+            <a:off x="5623560" y="3611880"/>
+            <a:ext cx="3246120" cy="2423160"/>
+          </a:xfrm>
+          <a:prstGeom prst="rect">
+            <a:avLst/>
+          </a:prstGeom>
+        </p:spPr>
+      </p:pic>
     </p:spTree>
   </p:cSld>
   <p:clrMapOvr>
@@ -4884,6 +5268,30 @@
           </a:p>
         </p:txBody>
       </p:sp>
+      <p:pic>
+        <p:nvPicPr>
+          <p:cNvPr id="4" name="Picture 3" descr="slide_03.jpg"/>
+          <p:cNvPicPr>
+            <a:picLocks noChangeAspect="1"/>
+          </p:cNvPicPr>
+          <p:nvPr/>
+        </p:nvPicPr>
+        <p:blipFill>
+          <a:blip r:embed="rId2"/>
+          <a:stretch>
+            <a:fillRect/>
+          </a:stretch>
+        </p:blipFill>
+        <p:spPr>
+          <a:xfrm>
+            <a:off x="5623560" y="3611880"/>
+            <a:ext cx="3246120" cy="2423160"/>
+          </a:xfrm>
+          <a:prstGeom prst="rect">
+            <a:avLst/>
+          </a:prstGeom>
+        </p:spPr>
+      </p:pic>
     </p:spTree>
   </p:cSld>
   <p:clrMapOvr>
@@ -4970,6 +5378,30 @@
           </a:p>
         </p:txBody>
       </p:sp>
+      <p:pic>
+        <p:nvPicPr>
+          <p:cNvPr id="4" name="Picture 3" descr="slide_03.jpg"/>
+          <p:cNvPicPr>
+            <a:picLocks noChangeAspect="1"/>
+          </p:cNvPicPr>
+          <p:nvPr/>
+        </p:nvPicPr>
+        <p:blipFill>
+          <a:blip r:embed="rId2"/>
+          <a:stretch>
+            <a:fillRect/>
+          </a:stretch>
+        </p:blipFill>
+        <p:spPr>
+          <a:xfrm>
+            <a:off x="5623560" y="3611880"/>
+            <a:ext cx="3246120" cy="2423160"/>
+          </a:xfrm>
+          <a:prstGeom prst="rect">
+            <a:avLst/>
+          </a:prstGeom>
+        </p:spPr>
+      </p:pic>
     </p:spTree>
   </p:cSld>
   <p:clrMapOvr>
@@ -5056,6 +5488,30 @@
           </a:p>
         </p:txBody>
       </p:sp>
+      <p:pic>
+        <p:nvPicPr>
+          <p:cNvPr id="4" name="Picture 3" descr="slide_01.jpg"/>
+          <p:cNvPicPr>
+            <a:picLocks noChangeAspect="1"/>
+          </p:cNvPicPr>
+          <p:nvPr/>
+        </p:nvPicPr>
+        <p:blipFill>
+          <a:blip r:embed="rId2"/>
+          <a:stretch>
+            <a:fillRect/>
+          </a:stretch>
+        </p:blipFill>
+        <p:spPr>
+          <a:xfrm>
+            <a:off x="5623560" y="3611880"/>
+            <a:ext cx="3246120" cy="2423160"/>
+          </a:xfrm>
+          <a:prstGeom prst="rect">
+            <a:avLst/>
+          </a:prstGeom>
+        </p:spPr>
+      </p:pic>
     </p:spTree>
   </p:cSld>
   <p:clrMapOvr>
@@ -5140,6 +5596,30 @@
           </a:p>
         </p:txBody>
       </p:sp>
+      <p:pic>
+        <p:nvPicPr>
+          <p:cNvPr id="4" name="Picture 3" descr="slide_05.jpg"/>
+          <p:cNvPicPr>
+            <a:picLocks noChangeAspect="1"/>
+          </p:cNvPicPr>
+          <p:nvPr/>
+        </p:nvPicPr>
+        <p:blipFill>
+          <a:blip r:embed="rId2"/>
+          <a:stretch>
+            <a:fillRect/>
+          </a:stretch>
+        </p:blipFill>
+        <p:spPr>
+          <a:xfrm>
+            <a:off x="5623560" y="3611880"/>
+            <a:ext cx="3246120" cy="2423160"/>
+          </a:xfrm>
+          <a:prstGeom prst="rect">
+            <a:avLst/>
+          </a:prstGeom>
+        </p:spPr>
+      </p:pic>
     </p:spTree>
   </p:cSld>
   <p:clrMapOvr>
@@ -5242,6 +5722,30 @@
           </a:p>
         </p:txBody>
       </p:sp>
+      <p:pic>
+        <p:nvPicPr>
+          <p:cNvPr id="4" name="Picture 3" descr="slide_06.jpg"/>
+          <p:cNvPicPr>
+            <a:picLocks noChangeAspect="1"/>
+          </p:cNvPicPr>
+          <p:nvPr/>
+        </p:nvPicPr>
+        <p:blipFill>
+          <a:blip r:embed="rId2"/>
+          <a:stretch>
+            <a:fillRect/>
+          </a:stretch>
+        </p:blipFill>
+        <p:spPr>
+          <a:xfrm>
+            <a:off x="5623560" y="3611880"/>
+            <a:ext cx="3246120" cy="2423160"/>
+          </a:xfrm>
+          <a:prstGeom prst="rect">
+            <a:avLst/>
+          </a:prstGeom>
+        </p:spPr>
+      </p:pic>
     </p:spTree>
   </p:cSld>
   <p:clrMapOvr>
@@ -5328,6 +5832,30 @@
           </a:p>
         </p:txBody>
       </p:sp>
+      <p:pic>
+        <p:nvPicPr>
+          <p:cNvPr id="4" name="Picture 3" descr="slide_07.jpg"/>
+          <p:cNvPicPr>
+            <a:picLocks noChangeAspect="1"/>
+          </p:cNvPicPr>
+          <p:nvPr/>
+        </p:nvPicPr>
+        <p:blipFill>
+          <a:blip r:embed="rId2"/>
+          <a:stretch>
+            <a:fillRect/>
+          </a:stretch>
+        </p:blipFill>
+        <p:spPr>
+          <a:xfrm>
+            <a:off x="5623560" y="3611880"/>
+            <a:ext cx="3246120" cy="2423160"/>
+          </a:xfrm>
+          <a:prstGeom prst="rect">
+            <a:avLst/>
+          </a:prstGeom>
+        </p:spPr>
+      </p:pic>
     </p:spTree>
   </p:cSld>
   <p:clrMapOvr>
@@ -5422,6 +5950,30 @@
           </a:p>
         </p:txBody>
       </p:sp>
+      <p:pic>
+        <p:nvPicPr>
+          <p:cNvPr id="4" name="Picture 3" descr="slide_08.jpg"/>
+          <p:cNvPicPr>
+            <a:picLocks noChangeAspect="1"/>
+          </p:cNvPicPr>
+          <p:nvPr/>
+        </p:nvPicPr>
+        <p:blipFill>
+          <a:blip r:embed="rId2"/>
+          <a:stretch>
+            <a:fillRect/>
+          </a:stretch>
+        </p:blipFill>
+        <p:spPr>
+          <a:xfrm>
+            <a:off x="5623560" y="3611880"/>
+            <a:ext cx="3246120" cy="2423160"/>
+          </a:xfrm>
+          <a:prstGeom prst="rect">
+            <a:avLst/>
+          </a:prstGeom>
+        </p:spPr>
+      </p:pic>
     </p:spTree>
   </p:cSld>
   <p:clrMapOvr>
@@ -5508,6 +6060,30 @@
           </a:p>
         </p:txBody>
       </p:sp>
+      <p:pic>
+        <p:nvPicPr>
+          <p:cNvPr id="4" name="Picture 3" descr="slide_09.jpg"/>
+          <p:cNvPicPr>
+            <a:picLocks noChangeAspect="1"/>
+          </p:cNvPicPr>
+          <p:nvPr/>
+        </p:nvPicPr>
+        <p:blipFill>
+          <a:blip r:embed="rId2"/>
+          <a:stretch>
+            <a:fillRect/>
+          </a:stretch>
+        </p:blipFill>
+        <p:spPr>
+          <a:xfrm>
+            <a:off x="5623560" y="3611880"/>
+            <a:ext cx="3246120" cy="2423160"/>
+          </a:xfrm>
+          <a:prstGeom prst="rect">
+            <a:avLst/>
+          </a:prstGeom>
+        </p:spPr>
+      </p:pic>
     </p:spTree>
   </p:cSld>
   <p:clrMapOvr>

</xml_diff>